<commit_message>
fix: add visual QA gate for PPT style samples
</commit_message>
<xml_diff>
--- a/effect-tests/style-library-v1/samples/style-sample-data-analytics.pptx
+++ b/effect-tests/style-library-v1/samples/style-sample-data-analytics.pptx
@@ -902,33 +902,86 @@
           </a:ln>
         </p:spPr>
       </p:sp>
-      <p:pic>
-        <p:nvPicPr>
-          <p:cNvPr id="3" name="Image 0" descr="/Users/dw/Desktop/codex-visual-asset-skills/effect-tests/style-library-v1/assets/background-data-analytics.png">    </p:cNvPr>
-          <p:cNvPicPr>
-            <a:picLocks noChangeAspect="1"/>
-          </p:cNvPicPr>
-          <p:nvPr/>
-        </p:nvPicPr>
-        <p:blipFill>
-          <a:blip r:embed="rId1"/>
-          <a:stretch>
-            <a:fillRect/>
-          </a:stretch>
-        </p:blipFill>
+      <p:sp>
+        <p:nvSpPr>
+          <p:cNvPr id="3" name="Shape 1"/>
+          <p:cNvSpPr/>
+          <p:nvPr/>
+        </p:nvSpPr>
         <p:spPr>
           <a:xfrm>
             <a:off x="0" y="0"/>
-            <a:ext cx="12191695" cy="6858000"/>
-          </a:xfrm>
-          <a:prstGeom prst="rect">
-            <a:avLst/>
-          </a:prstGeom>
-        </p:spPr>
-      </p:pic>
-      <p:sp>
-        <p:nvSpPr>
-          <p:cNvPr id="4" name="Text 1"/>
+            <a:ext cx="82296" cy="6858000"/>
+          </a:xfrm>
+          <a:prstGeom prst="rect">
+            <a:avLst/>
+          </a:prstGeom>
+          <a:solidFill>
+            <a:srgbClr val="6C72FF"/>
+          </a:solidFill>
+          <a:ln w="12700">
+            <a:solidFill>
+              <a:srgbClr val="6C72FF">
+                <a:alpha val="0"/>
+              </a:srgbClr>
+            </a:solidFill>
+            <a:prstDash val="solid"/>
+          </a:ln>
+        </p:spPr>
+      </p:sp>
+      <p:sp>
+        <p:nvSpPr>
+          <p:cNvPr id="4" name="Shape 2"/>
+          <p:cNvSpPr/>
+          <p:nvPr/>
+        </p:nvSpPr>
+        <p:spPr>
+          <a:xfrm>
+            <a:off x="10195560" y="841248"/>
+            <a:ext cx="685800" cy="530352"/>
+          </a:xfrm>
+          <a:prstGeom prst="line">
+            <a:avLst/>
+          </a:prstGeom>
+          <a:noFill/>
+          <a:ln w="15240">
+            <a:solidFill>
+              <a:srgbClr val="12C7D6">
+                <a:alpha val="42000"/>
+              </a:srgbClr>
+            </a:solidFill>
+            <a:prstDash val="solid"/>
+          </a:ln>
+        </p:spPr>
+      </p:sp>
+      <p:sp>
+        <p:nvSpPr>
+          <p:cNvPr id="5" name="Shape 3"/>
+          <p:cNvSpPr/>
+          <p:nvPr/>
+        </p:nvSpPr>
+        <p:spPr>
+          <a:xfrm>
+            <a:off x="10378440" y="5669280"/>
+            <a:ext cx="493776" cy="-384048"/>
+          </a:xfrm>
+          <a:prstGeom prst="line">
+            <a:avLst/>
+          </a:prstGeom>
+          <a:noFill/>
+          <a:ln w="12700">
+            <a:solidFill>
+              <a:srgbClr val="6C72FF">
+                <a:alpha val="38000"/>
+              </a:srgbClr>
+            </a:solidFill>
+            <a:prstDash val="solid"/>
+          </a:ln>
+        </p:spPr>
+      </p:sp>
+      <p:sp>
+        <p:nvSpPr>
+          <p:cNvPr id="6" name="Text 4"/>
           <p:cNvSpPr/>
           <p:nvPr/>
         </p:nvSpPr>
@@ -969,7 +1022,7 @@
       </p:sp>
       <p:sp>
         <p:nvSpPr>
-          <p:cNvPr id="5" name="Text 2"/>
+          <p:cNvPr id="7" name="Text 5"/>
           <p:cNvSpPr/>
           <p:nvPr/>
         </p:nvSpPr>
@@ -1010,7 +1063,7 @@
       </p:sp>
       <p:sp>
         <p:nvSpPr>
-          <p:cNvPr id="6" name="Text 3"/>
+          <p:cNvPr id="8" name="Text 6"/>
           <p:cNvSpPr/>
           <p:nvPr/>
         </p:nvSpPr>
@@ -1051,7 +1104,7 @@
       </p:sp>
       <p:sp>
         <p:nvSpPr>
-          <p:cNvPr id="7" name="Shape 4"/>
+          <p:cNvPr id="9" name="Shape 7"/>
           <p:cNvSpPr/>
           <p:nvPr/>
         </p:nvSpPr>
@@ -1076,7 +1129,7 @@
       </p:sp>
       <p:sp>
         <p:nvSpPr>
-          <p:cNvPr id="8" name="Text 5"/>
+          <p:cNvPr id="10" name="Text 8"/>
           <p:cNvSpPr/>
           <p:nvPr/>
         </p:nvSpPr>
@@ -1117,7 +1170,7 @@
       </p:sp>
       <p:sp>
         <p:nvSpPr>
-          <p:cNvPr id="9" name="Text 6"/>
+          <p:cNvPr id="11" name="Text 9"/>
           <p:cNvSpPr/>
           <p:nvPr/>
         </p:nvSpPr>
@@ -1158,7 +1211,7 @@
       </p:sp>
       <p:sp>
         <p:nvSpPr>
-          <p:cNvPr id="10" name="Shape 7"/>
+          <p:cNvPr id="12" name="Shape 10"/>
           <p:cNvSpPr/>
           <p:nvPr/>
         </p:nvSpPr>
@@ -1185,7 +1238,7 @@
       </p:sp>
       <p:sp>
         <p:nvSpPr>
-          <p:cNvPr id="11" name="Text 8"/>
+          <p:cNvPr id="13" name="Text 11"/>
           <p:cNvSpPr/>
           <p:nvPr/>
         </p:nvSpPr>
@@ -1226,7 +1279,7 @@
       </p:sp>
       <p:sp>
         <p:nvSpPr>
-          <p:cNvPr id="12" name="Shape 9"/>
+          <p:cNvPr id="14" name="Shape 12"/>
           <p:cNvSpPr/>
           <p:nvPr/>
         </p:nvSpPr>
@@ -1253,7 +1306,7 @@
       </p:sp>
       <p:sp>
         <p:nvSpPr>
-          <p:cNvPr id="13" name="Text 10"/>
+          <p:cNvPr id="15" name="Text 13"/>
           <p:cNvSpPr/>
           <p:nvPr/>
         </p:nvSpPr>
@@ -1294,7 +1347,7 @@
       </p:sp>
       <p:sp>
         <p:nvSpPr>
-          <p:cNvPr id="14" name="Shape 11"/>
+          <p:cNvPr id="16" name="Shape 14"/>
           <p:cNvSpPr/>
           <p:nvPr/>
         </p:nvSpPr>
@@ -1321,7 +1374,7 @@
       </p:sp>
       <p:sp>
         <p:nvSpPr>
-          <p:cNvPr id="15" name="Text 12"/>
+          <p:cNvPr id="17" name="Text 15"/>
           <p:cNvSpPr/>
           <p:nvPr/>
         </p:nvSpPr>
@@ -1362,7 +1415,7 @@
       </p:sp>
       <p:sp>
         <p:nvSpPr>
-          <p:cNvPr id="16" name="Shape 13"/>
+          <p:cNvPr id="18" name="Shape 16"/>
           <p:cNvSpPr/>
           <p:nvPr/>
         </p:nvSpPr>
@@ -1387,7 +1440,7 @@
       </p:sp>
       <p:sp>
         <p:nvSpPr>
-          <p:cNvPr id="17" name="Text 14"/>
+          <p:cNvPr id="19" name="Text 17"/>
           <p:cNvSpPr/>
           <p:nvPr/>
         </p:nvSpPr>
@@ -1428,7 +1481,7 @@
       </p:sp>
       <p:sp>
         <p:nvSpPr>
-          <p:cNvPr id="18" name="Text 15"/>
+          <p:cNvPr id="20" name="Text 18"/>
           <p:cNvSpPr/>
           <p:nvPr/>
         </p:nvSpPr>
@@ -1469,7 +1522,7 @@
       </p:sp>
       <p:sp>
         <p:nvSpPr>
-          <p:cNvPr id="19" name="Shape 16"/>
+          <p:cNvPr id="21" name="Shape 19"/>
           <p:cNvSpPr/>
           <p:nvPr/>
         </p:nvSpPr>
@@ -1494,7 +1547,7 @@
       </p:sp>
       <p:sp>
         <p:nvSpPr>
-          <p:cNvPr id="20" name="Text 17"/>
+          <p:cNvPr id="22" name="Text 20"/>
           <p:cNvSpPr/>
           <p:nvPr/>
         </p:nvSpPr>
@@ -1535,7 +1588,7 @@
       </p:sp>
       <p:sp>
         <p:nvSpPr>
-          <p:cNvPr id="21" name="Text 18"/>
+          <p:cNvPr id="23" name="Text 21"/>
           <p:cNvSpPr/>
           <p:nvPr/>
         </p:nvSpPr>
@@ -1576,7 +1629,7 @@
       </p:sp>
       <p:sp>
         <p:nvSpPr>
-          <p:cNvPr id="22" name="Shape 19"/>
+          <p:cNvPr id="24" name="Shape 22"/>
           <p:cNvSpPr/>
           <p:nvPr/>
         </p:nvSpPr>
@@ -1601,7 +1654,7 @@
       </p:sp>
       <p:sp>
         <p:nvSpPr>
-          <p:cNvPr id="23" name="Text 20"/>
+          <p:cNvPr id="25" name="Text 23"/>
           <p:cNvSpPr/>
           <p:nvPr/>
         </p:nvSpPr>
@@ -1642,7 +1695,7 @@
       </p:sp>
       <p:sp>
         <p:nvSpPr>
-          <p:cNvPr id="24" name="Text 21"/>
+          <p:cNvPr id="26" name="Text 24"/>
           <p:cNvSpPr/>
           <p:nvPr/>
         </p:nvSpPr>
@@ -1683,7 +1736,7 @@
       </p:sp>
       <p:sp>
         <p:nvSpPr>
-          <p:cNvPr id="25" name="Text 22"/>
+          <p:cNvPr id="27" name="Text 25"/>
           <p:cNvSpPr/>
           <p:nvPr/>
         </p:nvSpPr>
@@ -1724,7 +1777,7 @@
       </p:sp>
       <p:sp>
         <p:nvSpPr>
-          <p:cNvPr id="26" name="Shape 23"/>
+          <p:cNvPr id="28" name="Shape 26"/>
           <p:cNvSpPr/>
           <p:nvPr/>
         </p:nvSpPr>
@@ -1749,7 +1802,7 @@
       </p:sp>
       <p:sp>
         <p:nvSpPr>
-          <p:cNvPr id="27" name="Shape 24"/>
+          <p:cNvPr id="29" name="Shape 27"/>
           <p:cNvSpPr/>
           <p:nvPr/>
         </p:nvSpPr>
@@ -1774,7 +1827,7 @@
       </p:sp>
       <p:sp>
         <p:nvSpPr>
-          <p:cNvPr id="28" name="Shape 25"/>
+          <p:cNvPr id="30" name="Shape 28"/>
           <p:cNvSpPr/>
           <p:nvPr/>
         </p:nvSpPr>
@@ -1801,7 +1854,7 @@
       </p:sp>
       <p:sp>
         <p:nvSpPr>
-          <p:cNvPr id="29" name="Text 26"/>
+          <p:cNvPr id="31" name="Text 29"/>
           <p:cNvSpPr/>
           <p:nvPr/>
         </p:nvSpPr>
@@ -1842,7 +1895,7 @@
       </p:sp>
       <p:sp>
         <p:nvSpPr>
-          <p:cNvPr id="30" name="Shape 27"/>
+          <p:cNvPr id="32" name="Shape 30"/>
           <p:cNvSpPr/>
           <p:nvPr/>
         </p:nvSpPr>
@@ -1869,7 +1922,7 @@
       </p:sp>
       <p:sp>
         <p:nvSpPr>
-          <p:cNvPr id="31" name="Text 28"/>
+          <p:cNvPr id="33" name="Text 31"/>
           <p:cNvSpPr/>
           <p:nvPr/>
         </p:nvSpPr>
@@ -1910,7 +1963,7 @@
       </p:sp>
       <p:sp>
         <p:nvSpPr>
-          <p:cNvPr id="32" name="Shape 29"/>
+          <p:cNvPr id="34" name="Shape 32"/>
           <p:cNvSpPr/>
           <p:nvPr/>
         </p:nvSpPr>
@@ -1937,7 +1990,7 @@
       </p:sp>
       <p:sp>
         <p:nvSpPr>
-          <p:cNvPr id="33" name="Text 30"/>
+          <p:cNvPr id="35" name="Text 33"/>
           <p:cNvSpPr/>
           <p:nvPr/>
         </p:nvSpPr>
@@ -1978,7 +2031,7 @@
       </p:sp>
       <p:sp>
         <p:nvSpPr>
-          <p:cNvPr id="34" name="Shape 31"/>
+          <p:cNvPr id="36" name="Shape 34"/>
           <p:cNvSpPr/>
           <p:nvPr/>
         </p:nvSpPr>
@@ -2005,7 +2058,7 @@
       </p:sp>
       <p:sp>
         <p:nvSpPr>
-          <p:cNvPr id="35" name="Text 32"/>
+          <p:cNvPr id="37" name="Text 35"/>
           <p:cNvSpPr/>
           <p:nvPr/>
         </p:nvSpPr>

</xml_diff>

<commit_message>
fix: upgrade visual PPT style candidate quality
</commit_message>
<xml_diff>
--- a/effect-tests/style-library-v1/samples/style-sample-data-analytics.pptx
+++ b/effect-tests/style-library-v1/samples/style-sample-data-analytics.pptx
@@ -902,26 +902,52 @@
           </a:ln>
         </p:spPr>
       </p:sp>
-      <p:sp>
-        <p:nvSpPr>
-          <p:cNvPr id="3" name="Shape 1"/>
-          <p:cNvSpPr/>
-          <p:nvPr/>
-        </p:nvSpPr>
+      <p:pic>
+        <p:nvPicPr>
+          <p:cNvPr id="3" name="Image 0" descr="/Users/dw/Desktop/codex-visual-ppt-deck-builder/effect-tests/style-library-v1/assets/background-data-analytics.png">    </p:cNvPr>
+          <p:cNvPicPr>
+            <a:picLocks noChangeAspect="1"/>
+          </p:cNvPicPr>
+          <p:nvPr/>
+        </p:nvPicPr>
+        <p:blipFill>
+          <a:blip r:embed="rId1"/>
+          <a:stretch>
+            <a:fillRect/>
+          </a:stretch>
+        </p:blipFill>
         <p:spPr>
           <a:xfrm>
             <a:off x="0" y="0"/>
-            <a:ext cx="82296" cy="6858000"/>
-          </a:xfrm>
-          <a:prstGeom prst="rect">
-            <a:avLst/>
-          </a:prstGeom>
-          <a:solidFill>
-            <a:srgbClr val="6C72FF"/>
+            <a:ext cx="12191695" cy="6858000"/>
+          </a:xfrm>
+          <a:prstGeom prst="rect">
+            <a:avLst/>
+          </a:prstGeom>
+        </p:spPr>
+      </p:pic>
+      <p:sp>
+        <p:nvSpPr>
+          <p:cNvPr id="4" name="Shape 1"/>
+          <p:cNvSpPr/>
+          <p:nvPr/>
+        </p:nvSpPr>
+        <p:spPr>
+          <a:xfrm>
+            <a:off x="0" y="0"/>
+            <a:ext cx="12191695" cy="6858000"/>
+          </a:xfrm>
+          <a:prstGeom prst="rect">
+            <a:avLst/>
+          </a:prstGeom>
+          <a:solidFill>
+            <a:srgbClr val="020B1D">
+              <a:alpha val="76000"/>
+            </a:srgbClr>
           </a:solidFill>
           <a:ln w="12700">
             <a:solidFill>
-              <a:srgbClr val="6C72FF">
+              <a:srgbClr val="333333">
                 <a:alpha val="0"/>
               </a:srgbClr>
             </a:solidFill>
@@ -931,64 +957,14 @@
       </p:sp>
       <p:sp>
         <p:nvSpPr>
-          <p:cNvPr id="4" name="Shape 2"/>
-          <p:cNvSpPr/>
-          <p:nvPr/>
-        </p:nvSpPr>
-        <p:spPr>
-          <a:xfrm>
-            <a:off x="10195560" y="841248"/>
-            <a:ext cx="685800" cy="530352"/>
-          </a:xfrm>
-          <a:prstGeom prst="line">
-            <a:avLst/>
-          </a:prstGeom>
-          <a:noFill/>
-          <a:ln w="15240">
-            <a:solidFill>
-              <a:srgbClr val="12C7D6">
-                <a:alpha val="42000"/>
-              </a:srgbClr>
-            </a:solidFill>
-            <a:prstDash val="solid"/>
-          </a:ln>
-        </p:spPr>
-      </p:sp>
-      <p:sp>
-        <p:nvSpPr>
-          <p:cNvPr id="5" name="Shape 3"/>
-          <p:cNvSpPr/>
-          <p:nvPr/>
-        </p:nvSpPr>
-        <p:spPr>
-          <a:xfrm>
-            <a:off x="10378440" y="5669280"/>
-            <a:ext cx="493776" cy="-384048"/>
-          </a:xfrm>
-          <a:prstGeom prst="line">
-            <a:avLst/>
-          </a:prstGeom>
-          <a:noFill/>
-          <a:ln w="12700">
-            <a:solidFill>
-              <a:srgbClr val="6C72FF">
-                <a:alpha val="38000"/>
-              </a:srgbClr>
-            </a:solidFill>
-            <a:prstDash val="solid"/>
-          </a:ln>
-        </p:spPr>
-      </p:sp>
-      <p:sp>
-        <p:nvSpPr>
-          <p:cNvPr id="6" name="Text 4"/>
+          <p:cNvPr id="5" name="Text 2"/>
           <p:cNvSpPr/>
           <p:nvPr/>
         </p:nvSpPr>
         <p:spPr>
           <a:xfrm>
             <a:off x="658368" y="411480"/>
-            <a:ext cx="2011680" cy="164592"/>
+            <a:ext cx="2468880" cy="164592"/>
           </a:xfrm>
           <a:prstGeom prst="rect">
             <a:avLst/>
@@ -1010,11 +986,11 @@
                 <a:solidFill>
                   <a:srgbClr val="6C72FF"/>
                 </a:solidFill>
-                <a:latin typeface="PingFang SC" pitchFamily="34" charset="0"/>
-                <a:ea typeface="PingFang SC" pitchFamily="34" charset="-122"/>
-                <a:cs typeface="PingFang SC" pitchFamily="34" charset="-120"/>
+                <a:latin typeface="Avenir Next" pitchFamily="34" charset="0"/>
+                <a:ea typeface="Avenir Next" pitchFamily="34" charset="-122"/>
+                <a:cs typeface="Avenir Next" pitchFamily="34" charset="-120"/>
               </a:rPr>
-              <a:t>2026 RESEARCH</a:t>
+              <a:t>AI RESEARCH</a:t>
             </a:r>
             <a:endParaRPr lang="en-US" sz="750" dirty="0"/>
           </a:p>
@@ -1022,14 +998,14 @@
       </p:sp>
       <p:sp>
         <p:nvSpPr>
-          <p:cNvPr id="7" name="Text 5"/>
+          <p:cNvPr id="6" name="Text 3"/>
           <p:cNvSpPr/>
           <p:nvPr/>
         </p:nvSpPr>
         <p:spPr>
           <a:xfrm>
             <a:off x="658368" y="685800"/>
-            <a:ext cx="5212080" cy="777240"/>
+            <a:ext cx="5212080" cy="822960"/>
           </a:xfrm>
           <a:prstGeom prst="rect">
             <a:avLst/>
@@ -1051,9 +1027,9 @@
                 <a:solidFill>
                   <a:srgbClr val="FFFFFF"/>
                 </a:solidFill>
-                <a:latin typeface="PingFang SC" pitchFamily="34" charset="0"/>
-                <a:ea typeface="PingFang SC" pitchFamily="34" charset="-122"/>
-                <a:cs typeface="PingFang SC" pitchFamily="34" charset="-120"/>
+                <a:latin typeface="Hiragino Sans GB" pitchFamily="34" charset="0"/>
+                <a:ea typeface="Hiragino Sans GB" pitchFamily="34" charset="-122"/>
+                <a:cs typeface="Hiragino Sans GB" pitchFamily="34" charset="-120"/>
               </a:rPr>
               <a:t>2026 AI 应用趋势调研</a:t>
             </a:r>
@@ -1063,14 +1039,14 @@
       </p:sp>
       <p:sp>
         <p:nvSpPr>
-          <p:cNvPr id="8" name="Text 6"/>
+          <p:cNvPr id="7" name="Text 4"/>
           <p:cNvSpPr/>
           <p:nvPr/>
         </p:nvSpPr>
         <p:spPr>
           <a:xfrm>
             <a:off x="694944" y="1453896"/>
-            <a:ext cx="4114800" cy="228600"/>
+            <a:ext cx="4389120" cy="219456"/>
           </a:xfrm>
           <a:prstGeom prst="rect">
             <a:avLst/>
@@ -1088,7 +1064,7 @@
               <a:buNone/>
             </a:pPr>
             <a:r>
-              <a:rPr lang="en-US" sz="1050" b="1" dirty="0">
+              <a:rPr lang="en-US" sz="1020" b="1" dirty="0">
                 <a:solidFill>
                   <a:srgbClr val="6C72FF"/>
                 </a:solidFill>
@@ -1098,13 +1074,13 @@
               </a:rPr>
               <a:t>行业研究报告样张</a:t>
             </a:r>
-            <a:endParaRPr lang="en-US" sz="1050" dirty="0"/>
-          </a:p>
-        </p:txBody>
-      </p:sp>
-      <p:sp>
-        <p:nvSpPr>
-          <p:cNvPr id="9" name="Shape 7"/>
+            <a:endParaRPr lang="en-US" sz="1020" dirty="0"/>
+          </a:p>
+        </p:txBody>
+      </p:sp>
+      <p:sp>
+        <p:nvSpPr>
+          <p:cNvPr id="8" name="Shape 5"/>
           <p:cNvSpPr/>
           <p:nvPr/>
         </p:nvSpPr>
@@ -1129,14 +1105,14 @@
       </p:sp>
       <p:sp>
         <p:nvSpPr>
-          <p:cNvPr id="10" name="Text 8"/>
+          <p:cNvPr id="9" name="Text 6"/>
           <p:cNvSpPr/>
           <p:nvPr/>
         </p:nvSpPr>
         <p:spPr>
           <a:xfrm>
             <a:off x="749808" y="2148840"/>
-            <a:ext cx="1645920" cy="256032"/>
+            <a:ext cx="2011680" cy="256032"/>
           </a:xfrm>
           <a:prstGeom prst="rect">
             <a:avLst/>
@@ -1170,14 +1146,14 @@
       </p:sp>
       <p:sp>
         <p:nvSpPr>
-          <p:cNvPr id="11" name="Text 9"/>
+          <p:cNvPr id="10" name="Text 7"/>
           <p:cNvSpPr/>
           <p:nvPr/>
         </p:nvSpPr>
         <p:spPr>
           <a:xfrm>
             <a:off x="749808" y="2651760"/>
-            <a:ext cx="4480560" cy="603504"/>
+            <a:ext cx="4480560" cy="640080"/>
           </a:xfrm>
           <a:prstGeom prst="rect">
             <a:avLst/>
@@ -1211,7 +1187,7 @@
       </p:sp>
       <p:sp>
         <p:nvSpPr>
-          <p:cNvPr id="12" name="Shape 10"/>
+          <p:cNvPr id="11" name="Shape 8"/>
           <p:cNvSpPr/>
           <p:nvPr/>
         </p:nvSpPr>
@@ -1238,7 +1214,7 @@
       </p:sp>
       <p:sp>
         <p:nvSpPr>
-          <p:cNvPr id="13" name="Text 11"/>
+          <p:cNvPr id="12" name="Text 9"/>
           <p:cNvSpPr/>
           <p:nvPr/>
         </p:nvSpPr>
@@ -1279,7 +1255,7 @@
       </p:sp>
       <p:sp>
         <p:nvSpPr>
-          <p:cNvPr id="14" name="Shape 12"/>
+          <p:cNvPr id="13" name="Shape 10"/>
           <p:cNvSpPr/>
           <p:nvPr/>
         </p:nvSpPr>
@@ -1306,7 +1282,7 @@
       </p:sp>
       <p:sp>
         <p:nvSpPr>
-          <p:cNvPr id="15" name="Text 13"/>
+          <p:cNvPr id="14" name="Text 11"/>
           <p:cNvSpPr/>
           <p:nvPr/>
         </p:nvSpPr>
@@ -1347,7 +1323,7 @@
       </p:sp>
       <p:sp>
         <p:nvSpPr>
-          <p:cNvPr id="16" name="Shape 14"/>
+          <p:cNvPr id="15" name="Shape 12"/>
           <p:cNvSpPr/>
           <p:nvPr/>
         </p:nvSpPr>
@@ -1374,7 +1350,7 @@
       </p:sp>
       <p:sp>
         <p:nvSpPr>
-          <p:cNvPr id="17" name="Text 15"/>
+          <p:cNvPr id="16" name="Text 13"/>
           <p:cNvSpPr/>
           <p:nvPr/>
         </p:nvSpPr>
@@ -1415,7 +1391,7 @@
       </p:sp>
       <p:sp>
         <p:nvSpPr>
-          <p:cNvPr id="18" name="Shape 16"/>
+          <p:cNvPr id="17" name="Shape 14"/>
           <p:cNvSpPr/>
           <p:nvPr/>
         </p:nvSpPr>
@@ -1440,14 +1416,14 @@
       </p:sp>
       <p:sp>
         <p:nvSpPr>
-          <p:cNvPr id="19" name="Text 17"/>
+          <p:cNvPr id="18" name="Text 15"/>
           <p:cNvSpPr/>
           <p:nvPr/>
         </p:nvSpPr>
         <p:spPr>
           <a:xfrm>
             <a:off x="749808" y="5111496"/>
-            <a:ext cx="1527048" cy="329184"/>
+            <a:ext cx="1545336" cy="329184"/>
           </a:xfrm>
           <a:prstGeom prst="rect">
             <a:avLst/>
@@ -1469,9 +1445,9 @@
                 <a:solidFill>
                   <a:srgbClr val="6C72FF"/>
                 </a:solidFill>
-                <a:latin typeface="PingFang SC" pitchFamily="34" charset="0"/>
-                <a:ea typeface="PingFang SC" pitchFamily="34" charset="-122"/>
-                <a:cs typeface="PingFang SC" pitchFamily="34" charset="-120"/>
+                <a:latin typeface="Hiragino Sans GB" pitchFamily="34" charset="0"/>
+                <a:ea typeface="Hiragino Sans GB" pitchFamily="34" charset="-122"/>
+                <a:cs typeface="Hiragino Sans GB" pitchFamily="34" charset="-120"/>
               </a:rPr>
               <a:t>73%</a:t>
             </a:r>
@@ -1481,14 +1457,14 @@
       </p:sp>
       <p:sp>
         <p:nvSpPr>
-          <p:cNvPr id="20" name="Text 18"/>
+          <p:cNvPr id="19" name="Text 16"/>
           <p:cNvSpPr/>
           <p:nvPr/>
         </p:nvSpPr>
         <p:spPr>
           <a:xfrm>
             <a:off x="749808" y="5477256"/>
-            <a:ext cx="1527048" cy="228600"/>
+            <a:ext cx="1545336" cy="228600"/>
           </a:xfrm>
           <a:prstGeom prst="rect">
             <a:avLst/>
@@ -1522,7 +1498,7 @@
       </p:sp>
       <p:sp>
         <p:nvSpPr>
-          <p:cNvPr id="21" name="Shape 19"/>
+          <p:cNvPr id="20" name="Shape 17"/>
           <p:cNvSpPr/>
           <p:nvPr/>
         </p:nvSpPr>
@@ -1547,14 +1523,14 @@
       </p:sp>
       <p:sp>
         <p:nvSpPr>
-          <p:cNvPr id="22" name="Text 20"/>
+          <p:cNvPr id="21" name="Text 18"/>
           <p:cNvSpPr/>
           <p:nvPr/>
         </p:nvSpPr>
         <p:spPr>
           <a:xfrm>
             <a:off x="2441448" y="5111496"/>
-            <a:ext cx="1527048" cy="329184"/>
+            <a:ext cx="1545336" cy="329184"/>
           </a:xfrm>
           <a:prstGeom prst="rect">
             <a:avLst/>
@@ -1576,9 +1552,9 @@
                 <a:solidFill>
                   <a:srgbClr val="12C7D6"/>
                 </a:solidFill>
-                <a:latin typeface="PingFang SC" pitchFamily="34" charset="0"/>
-                <a:ea typeface="PingFang SC" pitchFamily="34" charset="-122"/>
-                <a:cs typeface="PingFang SC" pitchFamily="34" charset="-120"/>
+                <a:latin typeface="Hiragino Sans GB" pitchFamily="34" charset="0"/>
+                <a:ea typeface="Hiragino Sans GB" pitchFamily="34" charset="-122"/>
+                <a:cs typeface="Hiragino Sans GB" pitchFamily="34" charset="-120"/>
               </a:rPr>
               <a:t>3x</a:t>
             </a:r>
@@ -1588,14 +1564,14 @@
       </p:sp>
       <p:sp>
         <p:nvSpPr>
-          <p:cNvPr id="23" name="Text 21"/>
+          <p:cNvPr id="22" name="Text 19"/>
           <p:cNvSpPr/>
           <p:nvPr/>
         </p:nvSpPr>
         <p:spPr>
           <a:xfrm>
             <a:off x="2441448" y="5477256"/>
-            <a:ext cx="1527048" cy="228600"/>
+            <a:ext cx="1545336" cy="228600"/>
           </a:xfrm>
           <a:prstGeom prst="rect">
             <a:avLst/>
@@ -1629,7 +1605,7 @@
       </p:sp>
       <p:sp>
         <p:nvSpPr>
-          <p:cNvPr id="24" name="Shape 22"/>
+          <p:cNvPr id="23" name="Shape 20"/>
           <p:cNvSpPr/>
           <p:nvPr/>
         </p:nvSpPr>
@@ -1654,14 +1630,14 @@
       </p:sp>
       <p:sp>
         <p:nvSpPr>
-          <p:cNvPr id="25" name="Text 23"/>
+          <p:cNvPr id="24" name="Text 21"/>
           <p:cNvSpPr/>
           <p:nvPr/>
         </p:nvSpPr>
         <p:spPr>
           <a:xfrm>
             <a:off x="4133088" y="5111496"/>
-            <a:ext cx="1527048" cy="329184"/>
+            <a:ext cx="1545336" cy="329184"/>
           </a:xfrm>
           <a:prstGeom prst="rect">
             <a:avLst/>
@@ -1683,9 +1659,9 @@
                 <a:solidFill>
                   <a:srgbClr val="6C72FF"/>
                 </a:solidFill>
-                <a:latin typeface="PingFang SC" pitchFamily="34" charset="0"/>
-                <a:ea typeface="PingFang SC" pitchFamily="34" charset="-122"/>
-                <a:cs typeface="PingFang SC" pitchFamily="34" charset="-120"/>
+                <a:latin typeface="Hiragino Sans GB" pitchFamily="34" charset="0"/>
+                <a:ea typeface="Hiragino Sans GB" pitchFamily="34" charset="-122"/>
+                <a:cs typeface="Hiragino Sans GB" pitchFamily="34" charset="-120"/>
               </a:rPr>
               <a:t>12月</a:t>
             </a:r>
@@ -1695,14 +1671,14 @@
       </p:sp>
       <p:sp>
         <p:nvSpPr>
-          <p:cNvPr id="26" name="Text 24"/>
+          <p:cNvPr id="25" name="Text 22"/>
           <p:cNvSpPr/>
           <p:nvPr/>
         </p:nvSpPr>
         <p:spPr>
           <a:xfrm>
             <a:off x="4133088" y="5477256"/>
-            <a:ext cx="1527048" cy="228600"/>
+            <a:ext cx="1545336" cy="228600"/>
           </a:xfrm>
           <a:prstGeom prst="rect">
             <a:avLst/>
@@ -1736,14 +1712,14 @@
       </p:sp>
       <p:sp>
         <p:nvSpPr>
-          <p:cNvPr id="27" name="Text 25"/>
+          <p:cNvPr id="26" name="Text 23"/>
           <p:cNvSpPr/>
           <p:nvPr/>
         </p:nvSpPr>
         <p:spPr>
           <a:xfrm>
             <a:off x="6565392" y="1399032"/>
-            <a:ext cx="2011680" cy="237744"/>
+            <a:ext cx="2377440" cy="237744"/>
           </a:xfrm>
           <a:prstGeom prst="rect">
             <a:avLst/>
@@ -1777,14 +1753,14 @@
       </p:sp>
       <p:sp>
         <p:nvSpPr>
-          <p:cNvPr id="28" name="Shape 26"/>
-          <p:cNvSpPr/>
-          <p:nvPr/>
-        </p:nvSpPr>
-        <p:spPr>
-          <a:xfrm>
-            <a:off x="6565392" y="1783080"/>
-            <a:ext cx="4069080" cy="0"/>
+          <p:cNvPr id="27" name="Shape 24"/>
+          <p:cNvSpPr/>
+          <p:nvPr/>
+        </p:nvSpPr>
+        <p:spPr>
+          <a:xfrm>
+            <a:off x="6492240" y="1947672"/>
+            <a:ext cx="4160520" cy="0"/>
           </a:xfrm>
           <a:prstGeom prst="line">
             <a:avLst/>
@@ -1802,14 +1778,14 @@
       </p:sp>
       <p:sp>
         <p:nvSpPr>
-          <p:cNvPr id="29" name="Shape 27"/>
+          <p:cNvPr id="28" name="Shape 25"/>
           <p:cNvSpPr/>
           <p:nvPr/>
         </p:nvSpPr>
         <p:spPr>
           <a:xfrm>
             <a:off x="6492240" y="4882896"/>
-            <a:ext cx="4069080" cy="0"/>
+            <a:ext cx="4160520" cy="0"/>
           </a:xfrm>
           <a:prstGeom prst="line">
             <a:avLst/>
@@ -1827,14 +1803,43 @@
       </p:sp>
       <p:sp>
         <p:nvSpPr>
-          <p:cNvPr id="30" name="Shape 28"/>
-          <p:cNvSpPr/>
-          <p:nvPr/>
-        </p:nvSpPr>
-        <p:spPr>
-          <a:xfrm>
-            <a:off x="6693408" y="3734592"/>
-            <a:ext cx="765810" cy="1148304"/>
+          <p:cNvPr id="29" name="Shape 26"/>
+          <p:cNvSpPr/>
+          <p:nvPr/>
+        </p:nvSpPr>
+        <p:spPr>
+          <a:xfrm>
+            <a:off x="6665976" y="4007907"/>
+            <a:ext cx="843534" cy="874989"/>
+          </a:xfrm>
+          <a:prstGeom prst="rect">
+            <a:avLst/>
+          </a:prstGeom>
+          <a:solidFill>
+            <a:srgbClr val="6C72FF">
+              <a:alpha val="22000"/>
+            </a:srgbClr>
+          </a:solidFill>
+          <a:ln w="12700">
+            <a:solidFill>
+              <a:srgbClr val="333333">
+                <a:alpha val="0"/>
+              </a:srgbClr>
+            </a:solidFill>
+            <a:prstDash val="solid"/>
+          </a:ln>
+        </p:spPr>
+      </p:sp>
+      <p:sp>
+        <p:nvSpPr>
+          <p:cNvPr id="30" name="Shape 27"/>
+          <p:cNvSpPr/>
+          <p:nvPr/>
+        </p:nvSpPr>
+        <p:spPr>
+          <a:xfrm>
+            <a:off x="6693408" y="4035339"/>
+            <a:ext cx="788670" cy="847557"/>
           </a:xfrm>
           <a:prstGeom prst="rect">
             <a:avLst/>
@@ -1854,14 +1859,14 @@
       </p:sp>
       <p:sp>
         <p:nvSpPr>
-          <p:cNvPr id="31" name="Text 29"/>
+          <p:cNvPr id="31" name="Text 28"/>
           <p:cNvSpPr/>
           <p:nvPr/>
         </p:nvSpPr>
         <p:spPr>
           <a:xfrm>
             <a:off x="6656832" y="5010912"/>
-            <a:ext cx="838962" cy="164592"/>
+            <a:ext cx="861822" cy="164592"/>
           </a:xfrm>
           <a:prstGeom prst="rect">
             <a:avLst/>
@@ -1895,14 +1900,43 @@
       </p:sp>
       <p:sp>
         <p:nvSpPr>
-          <p:cNvPr id="32" name="Shape 30"/>
-          <p:cNvSpPr/>
-          <p:nvPr/>
-        </p:nvSpPr>
-        <p:spPr>
-          <a:xfrm>
-            <a:off x="7660386" y="3133100"/>
-            <a:ext cx="765810" cy="1749796"/>
+          <p:cNvPr id="32" name="Shape 29"/>
+          <p:cNvSpPr/>
+          <p:nvPr/>
+        </p:nvSpPr>
+        <p:spPr>
+          <a:xfrm>
+            <a:off x="7655814" y="3379074"/>
+            <a:ext cx="843534" cy="1503822"/>
+          </a:xfrm>
+          <a:prstGeom prst="rect">
+            <a:avLst/>
+          </a:prstGeom>
+          <a:solidFill>
+            <a:srgbClr val="12C7D6">
+              <a:alpha val="22000"/>
+            </a:srgbClr>
+          </a:solidFill>
+          <a:ln w="12700">
+            <a:solidFill>
+              <a:srgbClr val="333333">
+                <a:alpha val="0"/>
+              </a:srgbClr>
+            </a:solidFill>
+            <a:prstDash val="solid"/>
+          </a:ln>
+        </p:spPr>
+      </p:sp>
+      <p:sp>
+        <p:nvSpPr>
+          <p:cNvPr id="33" name="Shape 30"/>
+          <p:cNvSpPr/>
+          <p:nvPr/>
+        </p:nvSpPr>
+        <p:spPr>
+          <a:xfrm>
+            <a:off x="7683246" y="3406506"/>
+            <a:ext cx="788670" cy="1476390"/>
           </a:xfrm>
           <a:prstGeom prst="rect">
             <a:avLst/>
@@ -1922,14 +1956,14 @@
       </p:sp>
       <p:sp>
         <p:nvSpPr>
-          <p:cNvPr id="33" name="Text 31"/>
-          <p:cNvSpPr/>
-          <p:nvPr/>
-        </p:nvSpPr>
-        <p:spPr>
-          <a:xfrm>
-            <a:off x="7623810" y="5010912"/>
-            <a:ext cx="838962" cy="164592"/>
+          <p:cNvPr id="34" name="Text 31"/>
+          <p:cNvSpPr/>
+          <p:nvPr/>
+        </p:nvSpPr>
+        <p:spPr>
+          <a:xfrm>
+            <a:off x="7646670" y="5010912"/>
+            <a:ext cx="861822" cy="164592"/>
           </a:xfrm>
           <a:prstGeom prst="rect">
             <a:avLst/>
@@ -1963,14 +1997,43 @@
       </p:sp>
       <p:sp>
         <p:nvSpPr>
-          <p:cNvPr id="34" name="Shape 32"/>
-          <p:cNvSpPr/>
-          <p:nvPr/>
-        </p:nvSpPr>
-        <p:spPr>
-          <a:xfrm>
-            <a:off x="8627364" y="2750332"/>
-            <a:ext cx="765810" cy="2132564"/>
+          <p:cNvPr id="35" name="Shape 32"/>
+          <p:cNvSpPr/>
+          <p:nvPr/>
+        </p:nvSpPr>
+        <p:spPr>
+          <a:xfrm>
+            <a:off x="8645652" y="2914284"/>
+            <a:ext cx="843534" cy="1968612"/>
+          </a:xfrm>
+          <a:prstGeom prst="rect">
+            <a:avLst/>
+          </a:prstGeom>
+          <a:solidFill>
+            <a:srgbClr val="6C72FF">
+              <a:alpha val="22000"/>
+            </a:srgbClr>
+          </a:solidFill>
+          <a:ln w="12700">
+            <a:solidFill>
+              <a:srgbClr val="333333">
+                <a:alpha val="0"/>
+              </a:srgbClr>
+            </a:solidFill>
+            <a:prstDash val="solid"/>
+          </a:ln>
+        </p:spPr>
+      </p:sp>
+      <p:sp>
+        <p:nvSpPr>
+          <p:cNvPr id="36" name="Shape 33"/>
+          <p:cNvSpPr/>
+          <p:nvPr/>
+        </p:nvSpPr>
+        <p:spPr>
+          <a:xfrm>
+            <a:off x="8673084" y="2941716"/>
+            <a:ext cx="788670" cy="1941180"/>
           </a:xfrm>
           <a:prstGeom prst="rect">
             <a:avLst/>
@@ -1990,14 +2053,14 @@
       </p:sp>
       <p:sp>
         <p:nvSpPr>
-          <p:cNvPr id="35" name="Text 33"/>
-          <p:cNvSpPr/>
-          <p:nvPr/>
-        </p:nvSpPr>
-        <p:spPr>
-          <a:xfrm>
-            <a:off x="8590788" y="5010912"/>
-            <a:ext cx="838962" cy="164592"/>
+          <p:cNvPr id="37" name="Text 34"/>
+          <p:cNvSpPr/>
+          <p:nvPr/>
+        </p:nvSpPr>
+        <p:spPr>
+          <a:xfrm>
+            <a:off x="8636508" y="5010912"/>
+            <a:ext cx="861822" cy="164592"/>
           </a:xfrm>
           <a:prstGeom prst="rect">
             <a:avLst/>
@@ -2031,14 +2094,43 @@
       </p:sp>
       <p:sp>
         <p:nvSpPr>
-          <p:cNvPr id="36" name="Shape 34"/>
-          <p:cNvSpPr/>
-          <p:nvPr/>
-        </p:nvSpPr>
-        <p:spPr>
-          <a:xfrm>
-            <a:off x="9594342" y="2394905"/>
-            <a:ext cx="765810" cy="2487991"/>
+          <p:cNvPr id="38" name="Shape 35"/>
+          <p:cNvSpPr/>
+          <p:nvPr/>
+        </p:nvSpPr>
+        <p:spPr>
+          <a:xfrm>
+            <a:off x="9635490" y="2449495"/>
+            <a:ext cx="843534" cy="2433401"/>
+          </a:xfrm>
+          <a:prstGeom prst="rect">
+            <a:avLst/>
+          </a:prstGeom>
+          <a:solidFill>
+            <a:srgbClr val="12C7D6">
+              <a:alpha val="22000"/>
+            </a:srgbClr>
+          </a:solidFill>
+          <a:ln w="12700">
+            <a:solidFill>
+              <a:srgbClr val="333333">
+                <a:alpha val="0"/>
+              </a:srgbClr>
+            </a:solidFill>
+            <a:prstDash val="solid"/>
+          </a:ln>
+        </p:spPr>
+      </p:sp>
+      <p:sp>
+        <p:nvSpPr>
+          <p:cNvPr id="39" name="Shape 36"/>
+          <p:cNvSpPr/>
+          <p:nvPr/>
+        </p:nvSpPr>
+        <p:spPr>
+          <a:xfrm>
+            <a:off x="9662922" y="2476927"/>
+            <a:ext cx="788670" cy="2405969"/>
           </a:xfrm>
           <a:prstGeom prst="rect">
             <a:avLst/>
@@ -2058,14 +2150,14 @@
       </p:sp>
       <p:sp>
         <p:nvSpPr>
-          <p:cNvPr id="37" name="Text 35"/>
-          <p:cNvSpPr/>
-          <p:nvPr/>
-        </p:nvSpPr>
-        <p:spPr>
-          <a:xfrm>
-            <a:off x="9557766" y="5010912"/>
-            <a:ext cx="838962" cy="164592"/>
+          <p:cNvPr id="40" name="Text 37"/>
+          <p:cNvSpPr/>
+          <p:nvPr/>
+        </p:nvSpPr>
+        <p:spPr>
+          <a:xfrm>
+            <a:off x="9626346" y="5010912"/>
+            <a:ext cx="861822" cy="164592"/>
           </a:xfrm>
           <a:prstGeom prst="rect">
             <a:avLst/>
@@ -2094,6 +2186,296 @@
               <a:t>收益</a:t>
             </a:r>
             <a:endParaRPr lang="en-US" sz="680" dirty="0"/>
+          </a:p>
+        </p:txBody>
+      </p:sp>
+      <p:sp>
+        <p:nvSpPr>
+          <p:cNvPr id="41" name="Shape 38"/>
+          <p:cNvSpPr/>
+          <p:nvPr/>
+        </p:nvSpPr>
+        <p:spPr>
+          <a:xfrm>
+            <a:off x="7042023" y="3953043"/>
+            <a:ext cx="91440" cy="91440"/>
+          </a:xfrm>
+          <a:prstGeom prst="ellipse">
+            <a:avLst/>
+          </a:prstGeom>
+          <a:solidFill>
+            <a:srgbClr val="12C7D6"/>
+          </a:solidFill>
+          <a:ln w="12700">
+            <a:solidFill>
+              <a:srgbClr val="333333">
+                <a:alpha val="0"/>
+              </a:srgbClr>
+            </a:solidFill>
+            <a:prstDash val="solid"/>
+          </a:ln>
+        </p:spPr>
+      </p:sp>
+      <p:sp>
+        <p:nvSpPr>
+          <p:cNvPr id="42" name="Shape 39"/>
+          <p:cNvSpPr/>
+          <p:nvPr/>
+        </p:nvSpPr>
+        <p:spPr>
+          <a:xfrm>
+            <a:off x="8031861" y="3324210"/>
+            <a:ext cx="91440" cy="91440"/>
+          </a:xfrm>
+          <a:prstGeom prst="ellipse">
+            <a:avLst/>
+          </a:prstGeom>
+          <a:solidFill>
+            <a:srgbClr val="12C7D6"/>
+          </a:solidFill>
+          <a:ln w="12700">
+            <a:solidFill>
+              <a:srgbClr val="333333">
+                <a:alpha val="0"/>
+              </a:srgbClr>
+            </a:solidFill>
+            <a:prstDash val="solid"/>
+          </a:ln>
+        </p:spPr>
+      </p:sp>
+      <p:sp>
+        <p:nvSpPr>
+          <p:cNvPr id="43" name="Shape 40"/>
+          <p:cNvSpPr/>
+          <p:nvPr/>
+        </p:nvSpPr>
+        <p:spPr>
+          <a:xfrm>
+            <a:off x="9021699" y="2859420"/>
+            <a:ext cx="91440" cy="91440"/>
+          </a:xfrm>
+          <a:prstGeom prst="ellipse">
+            <a:avLst/>
+          </a:prstGeom>
+          <a:solidFill>
+            <a:srgbClr val="12C7D6"/>
+          </a:solidFill>
+          <a:ln w="12700">
+            <a:solidFill>
+              <a:srgbClr val="333333">
+                <a:alpha val="0"/>
+              </a:srgbClr>
+            </a:solidFill>
+            <a:prstDash val="solid"/>
+          </a:ln>
+        </p:spPr>
+      </p:sp>
+      <p:sp>
+        <p:nvSpPr>
+          <p:cNvPr id="44" name="Shape 41"/>
+          <p:cNvSpPr/>
+          <p:nvPr/>
+        </p:nvSpPr>
+        <p:spPr>
+          <a:xfrm>
+            <a:off x="10011537" y="2394631"/>
+            <a:ext cx="91440" cy="91440"/>
+          </a:xfrm>
+          <a:prstGeom prst="ellipse">
+            <a:avLst/>
+          </a:prstGeom>
+          <a:solidFill>
+            <a:srgbClr val="12C7D6"/>
+          </a:solidFill>
+          <a:ln w="12700">
+            <a:solidFill>
+              <a:srgbClr val="333333">
+                <a:alpha val="0"/>
+              </a:srgbClr>
+            </a:solidFill>
+            <a:prstDash val="solid"/>
+          </a:ln>
+        </p:spPr>
+      </p:sp>
+      <p:sp>
+        <p:nvSpPr>
+          <p:cNvPr id="45" name="Shape 42"/>
+          <p:cNvSpPr/>
+          <p:nvPr/>
+        </p:nvSpPr>
+        <p:spPr>
+          <a:xfrm>
+            <a:off x="7087743" y="3998763"/>
+            <a:ext cx="989838" cy="-628833"/>
+          </a:xfrm>
+          <a:prstGeom prst="line">
+            <a:avLst/>
+          </a:prstGeom>
+          <a:noFill/>
+          <a:ln w="17780">
+            <a:solidFill>
+              <a:srgbClr val="12C7D6">
+                <a:alpha val="82000"/>
+              </a:srgbClr>
+            </a:solidFill>
+            <a:prstDash val="solid"/>
+          </a:ln>
+        </p:spPr>
+      </p:sp>
+      <p:sp>
+        <p:nvSpPr>
+          <p:cNvPr id="46" name="Shape 43"/>
+          <p:cNvSpPr/>
+          <p:nvPr/>
+        </p:nvSpPr>
+        <p:spPr>
+          <a:xfrm>
+            <a:off x="8077581" y="3369930"/>
+            <a:ext cx="989838" cy="-464790"/>
+          </a:xfrm>
+          <a:prstGeom prst="line">
+            <a:avLst/>
+          </a:prstGeom>
+          <a:noFill/>
+          <a:ln w="17780">
+            <a:solidFill>
+              <a:srgbClr val="12C7D6">
+                <a:alpha val="82000"/>
+              </a:srgbClr>
+            </a:solidFill>
+            <a:prstDash val="solid"/>
+          </a:ln>
+        </p:spPr>
+      </p:sp>
+      <p:sp>
+        <p:nvSpPr>
+          <p:cNvPr id="47" name="Shape 44"/>
+          <p:cNvSpPr/>
+          <p:nvPr/>
+        </p:nvSpPr>
+        <p:spPr>
+          <a:xfrm>
+            <a:off x="9067419" y="2905140"/>
+            <a:ext cx="989838" cy="-464790"/>
+          </a:xfrm>
+          <a:prstGeom prst="line">
+            <a:avLst/>
+          </a:prstGeom>
+          <a:noFill/>
+          <a:ln w="17780">
+            <a:solidFill>
+              <a:srgbClr val="12C7D6">
+                <a:alpha val="82000"/>
+              </a:srgbClr>
+            </a:solidFill>
+            <a:prstDash val="solid"/>
+          </a:ln>
+        </p:spPr>
+      </p:sp>
+      <p:sp>
+        <p:nvSpPr>
+          <p:cNvPr id="48" name="Shape 45"/>
+          <p:cNvSpPr/>
+          <p:nvPr/>
+        </p:nvSpPr>
+        <p:spPr>
+          <a:xfrm>
+            <a:off x="749808" y="6254496"/>
+            <a:ext cx="475488" cy="0"/>
+          </a:xfrm>
+          <a:prstGeom prst="line">
+            <a:avLst/>
+          </a:prstGeom>
+          <a:noFill/>
+          <a:ln w="19050">
+            <a:solidFill>
+              <a:srgbClr val="6C72FF">
+                <a:alpha val="90000"/>
+              </a:srgbClr>
+            </a:solidFill>
+            <a:prstDash val="solid"/>
+          </a:ln>
+        </p:spPr>
+      </p:sp>
+      <p:sp>
+        <p:nvSpPr>
+          <p:cNvPr id="49" name="Text 46"/>
+          <p:cNvSpPr/>
+          <p:nvPr/>
+        </p:nvSpPr>
+        <p:spPr>
+          <a:xfrm>
+            <a:off x="1371600" y="6163056"/>
+            <a:ext cx="5669280" cy="164592"/>
+          </a:xfrm>
+          <a:prstGeom prst="rect">
+            <a:avLst/>
+          </a:prstGeom>
+          <a:noFill/>
+          <a:ln/>
+        </p:spPr>
+        <p:txBody>
+          <a:bodyPr wrap="square" lIns="0" tIns="0" rIns="0" bIns="0" rtlCol="0" anchor="ctr">
+            <a:normAutofit/>
+          </a:bodyPr>
+          <a:lstStyle/>
+          <a:p>
+            <a:pPr algn="l" indent="0" marL="0">
+              <a:buNone/>
+            </a:pPr>
+            <a:r>
+              <a:rPr lang="en-US" sz="740" dirty="0">
+                <a:solidFill>
+                  <a:srgbClr val="A7C3D9"/>
+                </a:solidFill>
+                <a:latin typeface="PingFang SC" pitchFamily="34" charset="0"/>
+                <a:ea typeface="PingFang SC" pitchFamily="34" charset="-122"/>
+                <a:cs typeface="PingFang SC" pitchFamily="34" charset="-120"/>
+              </a:rPr>
+              <a:t>文字、数字和图表标签均为 PPT 可编辑对象</a:t>
+            </a:r>
+            <a:endParaRPr lang="en-US" sz="740" dirty="0"/>
+          </a:p>
+        </p:txBody>
+      </p:sp>
+      <p:sp>
+        <p:nvSpPr>
+          <p:cNvPr id="50" name="Text 47"/>
+          <p:cNvSpPr/>
+          <p:nvPr/>
+        </p:nvSpPr>
+        <p:spPr>
+          <a:xfrm>
+            <a:off x="9875520" y="6291072"/>
+            <a:ext cx="914400" cy="146304"/>
+          </a:xfrm>
+          <a:prstGeom prst="rect">
+            <a:avLst/>
+          </a:prstGeom>
+          <a:noFill/>
+          <a:ln/>
+        </p:spPr>
+        <p:txBody>
+          <a:bodyPr wrap="square" lIns="0" tIns="0" rIns="0" bIns="0" rtlCol="0" anchor="ctr">
+            <a:normAutofit/>
+          </a:bodyPr>
+          <a:lstStyle/>
+          <a:p>
+            <a:pPr algn="r" indent="0" marL="0">
+              <a:buNone/>
+            </a:pPr>
+            <a:r>
+              <a:rPr lang="en-US" sz="720" b="1" dirty="0">
+                <a:solidFill>
+                  <a:srgbClr val="6C72FF"/>
+                </a:solidFill>
+                <a:latin typeface="Avenir Next" pitchFamily="34" charset="0"/>
+                <a:ea typeface="Avenir Next" pitchFamily="34" charset="-122"/>
+                <a:cs typeface="Avenir Next" pitchFamily="34" charset="-120"/>
+              </a:rPr>
+              <a:t>数据分析</a:t>
+            </a:r>
+            <a:endParaRPr lang="en-US" sz="720" dirty="0"/>
           </a:p>
         </p:txBody>
       </p:sp>

</xml_diff>